<commit_message>
Fix final poster review-scope labeling
</commit_message>
<xml_diff>
--- a/poster/PS2-FP10-Yiqiao-A0-Poster.pptx
+++ b/poster/PS2-FP10-Yiqiao-A0-Poster.pptx
@@ -2,13 +2,13 @@
 <file path=ppt/presentation.xml><?xml version="1.0" encoding="utf-8"?>
 <p:presentation xmlns:p="http://schemas.openxmlformats.org/presentationml/2006/main">
   <p:sldMasterIdLst>
-    <p:sldMasterId xmlns:r="http://schemas.openxmlformats.org/officeDocument/2006/relationships" id="2147483648" r:id="R085f84e5416348ee"/>
+    <p:sldMasterId xmlns:r="http://schemas.openxmlformats.org/officeDocument/2006/relationships" id="2147483648" r:id="Rb7fb34d72ad9423b"/>
   </p:sldMasterIdLst>
   <p:notesMasterIdLst>
-    <p:notesMasterId xmlns:r="http://schemas.openxmlformats.org/officeDocument/2006/relationships" r:id="R1eafbd00264247de"/>
+    <p:notesMasterId xmlns:r="http://schemas.openxmlformats.org/officeDocument/2006/relationships" r:id="Ra62d8a94d543418b"/>
   </p:notesMasterIdLst>
   <p:sldIdLst>
-    <p:sldId xmlns:r="http://schemas.openxmlformats.org/officeDocument/2006/relationships" id="256" r:id="R5842fc7f07604ccb"/>
+    <p:sldId xmlns:r="http://schemas.openxmlformats.org/officeDocument/2006/relationships" id="256" r:id="Rfa185b27eafc4edd"/>
   </p:sldIdLst>
   <p:sldSz cx="42804000" cy="30276000"/>
   <p:notesSz cx="6858000" cy="9144000"/>
@@ -525,7 +525,7 @@
   </p:cSld>
   <p:clrMap bg1="lt1" tx1="dk1" bg2="lt2" tx2="dk2" accent1="accent1" accent2="accent2" accent3="accent3" accent4="accent4" accent5="accent5" accent6="accent6" hlink="hlink" folHlink="folHlink"/>
   <p:sldLayoutIdLst>
-    <p:sldLayoutId xmlns:r="http://schemas.openxmlformats.org/officeDocument/2006/relationships" id="2147483649" r:id="Rf60e137f053d4891"/>
+    <p:sldLayoutId xmlns:r="http://schemas.openxmlformats.org/officeDocument/2006/relationships" id="2147483649" r:id="R45da44fbf25d4090"/>
   </p:sldLayoutIdLst>
   <p:txStyles>
     <p:titleStyle>
@@ -1441,14 +1441,14 @@
       </p:sp>
       <p:pic>
         <p:nvPicPr>
-          <p:cNvPr id="175" name=""/>
+          <p:cNvPr id="257" name=""/>
           <p:cNvPicPr>
             <a:picLocks xmlns:a="http://schemas.openxmlformats.org/drawingml/2006/main" noChangeAspect="1"/>
           </p:cNvPicPr>
           <p:nvPr/>
         </p:nvPicPr>
         <p:blipFill>
-          <a:blip xmlns:r="http://schemas.openxmlformats.org/officeDocument/2006/relationships" xmlns:a="http://schemas.openxmlformats.org/drawingml/2006/main" r:embed="Rbbf9b896146d4868"/>
+          <a:blip xmlns:r="http://schemas.openxmlformats.org/officeDocument/2006/relationships" xmlns:a="http://schemas.openxmlformats.org/drawingml/2006/main" r:embed="R7dd1910c1b914462"/>
           <a:stretch xmlns:a="http://schemas.openxmlformats.org/drawingml/2006/main"/>
         </p:blipFill>
         <p:spPr>
@@ -4363,7 +4363,18 @@
                 <a:ea typeface="Calibri"/>
                 <a:cs typeface="Calibri"/>
               </a:rPr>
-              <a:t>REVIEWER QUESTION  At what congestion and confidentiality conditions should enhanced access become conditional without creating excessive disclosure or unequal access?</a:t>
+              <a:t>OPEN DESIGN QUESTION</a:t>
+            </a:r>
+            <a:r>
+              <a:rPr sz="1950" b="0">
+                <a:solidFill>
+                  <a:srgbClr val="17243A"/>
+                </a:solidFill>
+                <a:latin typeface="Calibri"/>
+                <a:ea typeface="Calibri"/>
+                <a:cs typeface="Calibri"/>
+              </a:rPr>
+              <a:t>  At what congestion and confidentiality conditions should enhanced access become conditional without creating excessive disclosure or unequal access?</a:t>
             </a:r>
           </a:p>
         </p:txBody>
@@ -4453,7 +4464,18 @@
                 <a:cs typeface="Calibri"/>
               </a:rPr>
               <a:t>Superseded-version review only; no final-topic review.
-Checkpoint:</a:t>
+</a:t>
+            </a:r>
+            <a:r>
+              <a:rPr sz="2025" b="1">
+                <a:solidFill>
+                  <a:srgbClr val="006633"/>
+                </a:solidFill>
+                <a:latin typeface="Calibri"/>
+                <a:ea typeface="Calibri"/>
+                <a:cs typeface="Calibri"/>
+              </a:rPr>
+              <a:t>Validated computational checkpoint:</a:t>
             </a:r>
             <a:r>
               <a:rPr sz="2025" b="1">
@@ -4965,7 +4987,7 @@
                 <a:latin typeface="Calibri"/>
                 <a:ea typeface="Calibri"/>
                 <a:cs typeface="Calibri"/>
-                <a:hlinkClick xmlns:r="http://schemas.openxmlformats.org/officeDocument/2006/relationships" r:id="R1dbeecf03cf440cb"/>
+                <a:hlinkClick xmlns:r="http://schemas.openxmlformats.org/officeDocument/2006/relationships" r:id="R2582c077ee3b4362"/>
               </a:rPr>
               <a:t>GitHub · code + reproducibility</a:t>
             </a:r>
@@ -4993,7 +5015,7 @@
                 <a:latin typeface="Calibri"/>
                 <a:ea typeface="Calibri"/>
                 <a:cs typeface="Calibri"/>
-                <a:hlinkClick xmlns:r="http://schemas.openxmlformats.org/officeDocument/2006/relationships" r:id="Re3e9527452be4137"/>
+                <a:hlinkClick xmlns:r="http://schemas.openxmlformats.org/officeDocument/2006/relationships" r:id="Rab90a29058374da7"/>
               </a:rPr>
               <a:t>HF · try the decision lab</a:t>
             </a:r>
@@ -5021,7 +5043,7 @@
                 <a:latin typeface="Calibri"/>
                 <a:ea typeface="Calibri"/>
                 <a:cs typeface="Calibri"/>
-                <a:hlinkClick xmlns:r="http://schemas.openxmlformats.org/officeDocument/2006/relationships" r:id="R5f7333562e1443d6"/>
+                <a:hlinkClick xmlns:r="http://schemas.openxmlformats.org/officeDocument/2006/relationships" r:id="R9a35b6b8621e4133"/>
               </a:rPr>
               <a:t>Colab 01 · BNE / welfare / CCAR</a:t>
             </a:r>
@@ -5044,7 +5066,7 @@
                 <a:latin typeface="Calibri"/>
                 <a:ea typeface="Calibri"/>
                 <a:cs typeface="Calibri"/>
-                <a:hlinkClick xmlns:r="http://schemas.openxmlformats.org/officeDocument/2006/relationships" r:id="R49564dc0676447e1"/>
+                <a:hlinkClick xmlns:r="http://schemas.openxmlformats.org/officeDocument/2006/relationships" r:id="Rf231c24765734c92"/>
               </a:rPr>
               <a:t>Colab 02 · allocation</a:t>
             </a:r>
@@ -6186,7 +6208,7 @@
       </p:sp>
       <p:cxnSp>
         <p:nvCxnSpPr>
-          <p:cNvPr id="229" name=""/>
+          <p:cNvPr id="311" name=""/>
           <p:cNvCxnSpPr>
             <a:stCxn xmlns:a="http://schemas.openxmlformats.org/drawingml/2006/main" id="55" idx="3"/>
             <a:endCxn xmlns:a="http://schemas.openxmlformats.org/drawingml/2006/main" id="56" idx="1"/>
@@ -6212,7 +6234,7 @@
       </p:cxnSp>
       <p:cxnSp>
         <p:nvCxnSpPr>
-          <p:cNvPr id="230" name=""/>
+          <p:cNvPr id="312" name=""/>
           <p:cNvCxnSpPr>
             <a:stCxn xmlns:a="http://schemas.openxmlformats.org/drawingml/2006/main" id="56" idx="3"/>
             <a:endCxn xmlns:a="http://schemas.openxmlformats.org/drawingml/2006/main" id="57" idx="1"/>
@@ -6238,7 +6260,7 @@
       </p:cxnSp>
       <p:cxnSp>
         <p:nvCxnSpPr>
-          <p:cNvPr id="231" name=""/>
+          <p:cNvPr id="313" name=""/>
           <p:cNvCxnSpPr>
             <a:stCxn xmlns:a="http://schemas.openxmlformats.org/drawingml/2006/main" id="57" idx="3"/>
             <a:endCxn xmlns:a="http://schemas.openxmlformats.org/drawingml/2006/main" id="58" idx="1"/>
@@ -6264,7 +6286,7 @@
       </p:cxnSp>
       <p:cxnSp>
         <p:nvCxnSpPr>
-          <p:cNvPr id="232" name=""/>
+          <p:cNvPr id="314" name=""/>
           <p:cNvCxnSpPr>
             <a:stCxn xmlns:a="http://schemas.openxmlformats.org/drawingml/2006/main" id="58" idx="2"/>
             <a:endCxn xmlns:a="http://schemas.openxmlformats.org/drawingml/2006/main" id="59" idx="0"/>
@@ -6293,7 +6315,7 @@
       </p:cxnSp>
       <p:cxnSp>
         <p:nvCxnSpPr>
-          <p:cNvPr id="233" name=""/>
+          <p:cNvPr id="315" name=""/>
           <p:cNvCxnSpPr>
             <a:stCxn xmlns:a="http://schemas.openxmlformats.org/drawingml/2006/main" id="59" idx="3"/>
             <a:endCxn xmlns:a="http://schemas.openxmlformats.org/drawingml/2006/main" id="60" idx="1"/>
@@ -6319,7 +6341,7 @@
       </p:cxnSp>
       <p:cxnSp>
         <p:nvCxnSpPr>
-          <p:cNvPr id="234" name=""/>
+          <p:cNvPr id="316" name=""/>
           <p:cNvCxnSpPr>
             <a:stCxn xmlns:a="http://schemas.openxmlformats.org/drawingml/2006/main" id="60" idx="3"/>
             <a:endCxn xmlns:a="http://schemas.openxmlformats.org/drawingml/2006/main" id="61" idx="1"/>
@@ -6345,7 +6367,7 @@
       </p:cxnSp>
       <p:cxnSp>
         <p:nvCxnSpPr>
-          <p:cNvPr id="235" name=""/>
+          <p:cNvPr id="317" name=""/>
           <p:cNvCxnSpPr>
             <a:stCxn xmlns:a="http://schemas.openxmlformats.org/drawingml/2006/main" id="61" idx="3"/>
             <a:endCxn xmlns:a="http://schemas.openxmlformats.org/drawingml/2006/main" id="62" idx="1"/>
@@ -6432,7 +6454,7 @@
       </p:sp>
       <p:graphicFrame>
         <p:nvGraphicFramePr>
-          <p:cNvPr id="237" name=""/>
+          <p:cNvPr id="319" name=""/>
           <p:cNvGraphicFramePr/>
           <p:nvPr/>
         </p:nvGraphicFramePr>
@@ -7463,7 +7485,7 @@
       </p:sp>
       <p:cxnSp>
         <p:nvCxnSpPr>
-          <p:cNvPr id="246" name=""/>
+          <p:cNvPr id="328" name=""/>
           <p:cNvCxnSpPr>
             <a:stCxn xmlns:a="http://schemas.openxmlformats.org/drawingml/2006/main" id="78" idx="3"/>
             <a:endCxn xmlns:a="http://schemas.openxmlformats.org/drawingml/2006/main" id="79" idx="1"/>
@@ -7645,14 +7667,14 @@
       </p:sp>
       <p:pic>
         <p:nvPicPr>
-          <p:cNvPr id="249" name=""/>
+          <p:cNvPr id="331" name=""/>
           <p:cNvPicPr>
             <a:picLocks xmlns:a="http://schemas.openxmlformats.org/drawingml/2006/main" noChangeAspect="1"/>
           </p:cNvPicPr>
           <p:nvPr/>
         </p:nvPicPr>
         <p:blipFill>
-          <a:blip xmlns:r="http://schemas.openxmlformats.org/officeDocument/2006/relationships" xmlns:a="http://schemas.openxmlformats.org/drawingml/2006/main" r:embed="Ra71847ea86d24a95"/>
+          <a:blip xmlns:r="http://schemas.openxmlformats.org/officeDocument/2006/relationships" xmlns:a="http://schemas.openxmlformats.org/drawingml/2006/main" r:embed="Re80248d219c34502"/>
           <a:stretch xmlns:a="http://schemas.openxmlformats.org/drawingml/2006/main"/>
         </p:blipFill>
         <p:spPr>
@@ -7667,14 +7689,14 @@
       </p:pic>
       <p:pic>
         <p:nvPicPr>
-          <p:cNvPr id="250" name=""/>
+          <p:cNvPr id="332" name=""/>
           <p:cNvPicPr>
             <a:picLocks xmlns:a="http://schemas.openxmlformats.org/drawingml/2006/main" noChangeAspect="1"/>
           </p:cNvPicPr>
           <p:nvPr/>
         </p:nvPicPr>
         <p:blipFill>
-          <a:blip xmlns:r="http://schemas.openxmlformats.org/officeDocument/2006/relationships" xmlns:a="http://schemas.openxmlformats.org/drawingml/2006/main" r:embed="R07ada6faf11340e8"/>
+          <a:blip xmlns:r="http://schemas.openxmlformats.org/officeDocument/2006/relationships" xmlns:a="http://schemas.openxmlformats.org/drawingml/2006/main" r:embed="Rbf052f8f39884e3f"/>
           <a:stretch xmlns:a="http://schemas.openxmlformats.org/drawingml/2006/main"/>
         </p:blipFill>
         <p:spPr>

</xml_diff>